<commit_message>
feat(social): add Threads link site-wide + sync docs to v1.2
Threads (@2023_tiya) wired in three places to match the existing
FB/IG pattern:

- Social section: new third card with official Threads SVG icon,
  desktop grid bumped from 1fr 1fr to repeat(3, 1fr) — mobile
  remains single-column stack.
- Footer follow row: dot-separated link after FB and IG.
- Column submit-channels: new icon button alongside FB and IG.

Docs/slides bumped to v1.2:
- website-recommendations.md — 1.1 table Social row updated to
  show all four channels with single ✅; 3.7 Social drops the
  "should add Threads" recommendation (now shows as already done
  with the date in line with the legend).
- outline.md — same two textual updates to keep parity with the
  full doc.
- tiya-website-recommendations.pptx — regenerated; Slide 4 (網站架構
  table) and Slide 14 (改進建議 2/2) reflect the new state.

Co-Authored-By: Claude Opus 4.7 <noreply@anthropic.com>
</commit_message>
<xml_diff>
--- a/docs/slides/tiya-website-recommendations.pptx
+++ b/docs/slides/tiya-website-recommendations.pptx
@@ -5408,7 +5408,7 @@
                 <a:ea typeface="Noto Sans TC" pitchFamily="34" charset="-122"/>
                 <a:cs typeface="Noto Sans TC" pitchFamily="34" charset="-120"/>
               </a:rPr>
-              <a:t>加入 Threads 連結（協會已有官方帳號）。</a:t>
+              <a:t>已加入 Threads 連結（2026-05-17 完成）。</a:t>
             </a:r>
             <a:endParaRPr lang="en-US" sz="1500" dirty="0"/>
           </a:p>
@@ -11469,7 +11469,7 @@
                 <a:ea typeface="Noto Sans TC" pitchFamily="34" charset="-122"/>
                 <a:cs typeface="Noto Sans TC" pitchFamily="34" charset="-120"/>
               </a:rPr>
-              <a:t>FB、IG、Email</a:t>
+              <a:t>FB、IG、Threads、Email</a:t>
             </a:r>
             <a:endParaRPr lang="en-US" sz="1600" dirty="0"/>
           </a:p>
@@ -11508,7 +11508,7 @@
                 <a:ea typeface="Noto Sans TC" pitchFamily="34" charset="-122"/>
                 <a:cs typeface="Noto Sans TC" pitchFamily="34" charset="-120"/>
               </a:rPr>
-              <a:t>✅ 可加 Threads</a:t>
+              <a:t>✅</a:t>
             </a:r>
             <a:endParaRPr lang="en-US" sz="1600" dirty="0"/>
           </a:p>

</xml_diff>